<commit_message>
adding pretraning and eval step
</commit_message>
<xml_diff>
--- a/draft_BP/Dataset.pptx
+++ b/draft_BP/Dataset.pptx
@@ -11,6 +11,9 @@
     <p:sldId id="257" r:id="rId5"/>
     <p:sldId id="258" r:id="rId6"/>
     <p:sldId id="260" r:id="rId7"/>
+    <p:sldId id="262" r:id="rId8"/>
+    <p:sldId id="263" r:id="rId9"/>
+    <p:sldId id="264" r:id="rId10"/>
   </p:sldIdLst>
   <p:sldSz cx="12192000" cy="6858000"/>
   <p:notesSz cx="6858000" cy="9144000"/>
@@ -266,7 +269,7 @@
           <a:p>
             <a:fld id="{0003E177-A4D5-47C5-B4D4-EBE3B5C1083B}" type="datetimeFigureOut">
               <a:rPr lang="en-DK" smtClean="0"/>
-              <a:t>06/11/2025</a:t>
+              <a:t>26/11/2025</a:t>
             </a:fld>
             <a:endParaRPr lang="en-DK"/>
           </a:p>
@@ -466,7 +469,7 @@
           <a:p>
             <a:fld id="{0003E177-A4D5-47C5-B4D4-EBE3B5C1083B}" type="datetimeFigureOut">
               <a:rPr lang="en-DK" smtClean="0"/>
-              <a:t>06/11/2025</a:t>
+              <a:t>26/11/2025</a:t>
             </a:fld>
             <a:endParaRPr lang="en-DK"/>
           </a:p>
@@ -676,7 +679,7 @@
           <a:p>
             <a:fld id="{0003E177-A4D5-47C5-B4D4-EBE3B5C1083B}" type="datetimeFigureOut">
               <a:rPr lang="en-DK" smtClean="0"/>
-              <a:t>06/11/2025</a:t>
+              <a:t>26/11/2025</a:t>
             </a:fld>
             <a:endParaRPr lang="en-DK"/>
           </a:p>
@@ -876,7 +879,7 @@
           <a:p>
             <a:fld id="{0003E177-A4D5-47C5-B4D4-EBE3B5C1083B}" type="datetimeFigureOut">
               <a:rPr lang="en-DK" smtClean="0"/>
-              <a:t>06/11/2025</a:t>
+              <a:t>26/11/2025</a:t>
             </a:fld>
             <a:endParaRPr lang="en-DK"/>
           </a:p>
@@ -1152,7 +1155,7 @@
           <a:p>
             <a:fld id="{0003E177-A4D5-47C5-B4D4-EBE3B5C1083B}" type="datetimeFigureOut">
               <a:rPr lang="en-DK" smtClean="0"/>
-              <a:t>06/11/2025</a:t>
+              <a:t>26/11/2025</a:t>
             </a:fld>
             <a:endParaRPr lang="en-DK"/>
           </a:p>
@@ -1420,7 +1423,7 @@
           <a:p>
             <a:fld id="{0003E177-A4D5-47C5-B4D4-EBE3B5C1083B}" type="datetimeFigureOut">
               <a:rPr lang="en-DK" smtClean="0"/>
-              <a:t>06/11/2025</a:t>
+              <a:t>26/11/2025</a:t>
             </a:fld>
             <a:endParaRPr lang="en-DK"/>
           </a:p>
@@ -1835,7 +1838,7 @@
           <a:p>
             <a:fld id="{0003E177-A4D5-47C5-B4D4-EBE3B5C1083B}" type="datetimeFigureOut">
               <a:rPr lang="en-DK" smtClean="0"/>
-              <a:t>06/11/2025</a:t>
+              <a:t>26/11/2025</a:t>
             </a:fld>
             <a:endParaRPr lang="en-DK"/>
           </a:p>
@@ -1977,7 +1980,7 @@
           <a:p>
             <a:fld id="{0003E177-A4D5-47C5-B4D4-EBE3B5C1083B}" type="datetimeFigureOut">
               <a:rPr lang="en-DK" smtClean="0"/>
-              <a:t>06/11/2025</a:t>
+              <a:t>26/11/2025</a:t>
             </a:fld>
             <a:endParaRPr lang="en-DK"/>
           </a:p>
@@ -2090,7 +2093,7 @@
           <a:p>
             <a:fld id="{0003E177-A4D5-47C5-B4D4-EBE3B5C1083B}" type="datetimeFigureOut">
               <a:rPr lang="en-DK" smtClean="0"/>
-              <a:t>06/11/2025</a:t>
+              <a:t>26/11/2025</a:t>
             </a:fld>
             <a:endParaRPr lang="en-DK"/>
           </a:p>
@@ -2403,7 +2406,7 @@
           <a:p>
             <a:fld id="{0003E177-A4D5-47C5-B4D4-EBE3B5C1083B}" type="datetimeFigureOut">
               <a:rPr lang="en-DK" smtClean="0"/>
-              <a:t>06/11/2025</a:t>
+              <a:t>26/11/2025</a:t>
             </a:fld>
             <a:endParaRPr lang="en-DK"/>
           </a:p>
@@ -2692,7 +2695,7 @@
           <a:p>
             <a:fld id="{0003E177-A4D5-47C5-B4D4-EBE3B5C1083B}" type="datetimeFigureOut">
               <a:rPr lang="en-DK" smtClean="0"/>
-              <a:t>06/11/2025</a:t>
+              <a:t>26/11/2025</a:t>
             </a:fld>
             <a:endParaRPr lang="en-DK"/>
           </a:p>
@@ -2935,7 +2938,7 @@
           <a:p>
             <a:fld id="{0003E177-A4D5-47C5-B4D4-EBE3B5C1083B}" type="datetimeFigureOut">
               <a:rPr lang="en-DK" smtClean="0"/>
-              <a:t>06/11/2025</a:t>
+              <a:t>26/11/2025</a:t>
             </a:fld>
             <a:endParaRPr lang="en-DK"/>
           </a:p>
@@ -4186,6 +4189,348 @@
     <p:extLst>
       <p:ext uri="{BB962C8B-B14F-4D97-AF65-F5344CB8AC3E}">
         <p14:creationId xmlns:p14="http://schemas.microsoft.com/office/powerpoint/2010/main" val="3191837760"/>
+      </p:ext>
+    </p:extLst>
+  </p:cSld>
+  <p:clrMapOvr>
+    <a:masterClrMapping/>
+  </p:clrMapOvr>
+</p:sld>
+</file>
+
+<file path=ppt/slides/slide7.xml><?xml version="1.0" encoding="utf-8"?>
+<p:sld xmlns:a="http://schemas.openxmlformats.org/drawingml/2006/main" xmlns:r="http://schemas.openxmlformats.org/officeDocument/2006/relationships" xmlns:p="http://schemas.openxmlformats.org/presentationml/2006/main">
+  <p:cSld>
+    <p:spTree>
+      <p:nvGrpSpPr>
+        <p:cNvPr id="1" name=""/>
+        <p:cNvGrpSpPr/>
+        <p:nvPr/>
+      </p:nvGrpSpPr>
+      <p:grpSpPr>
+        <a:xfrm>
+          <a:off x="0" y="0"/>
+          <a:ext cx="0" cy="0"/>
+          <a:chOff x="0" y="0"/>
+          <a:chExt cx="0" cy="0"/>
+        </a:xfrm>
+      </p:grpSpPr>
+      <p:sp>
+        <p:nvSpPr>
+          <p:cNvPr id="2" name="Title 1">
+            <a:extLst>
+              <a:ext uri="{FF2B5EF4-FFF2-40B4-BE49-F238E27FC236}">
+                <a16:creationId xmlns:a16="http://schemas.microsoft.com/office/drawing/2014/main" id="{7547F5CE-4474-2AB3-D988-946D8E6C7F32}"/>
+              </a:ext>
+            </a:extLst>
+          </p:cNvPr>
+          <p:cNvSpPr>
+            <a:spLocks noGrp="1"/>
+          </p:cNvSpPr>
+          <p:nvPr>
+            <p:ph type="title"/>
+          </p:nvPr>
+        </p:nvSpPr>
+        <p:spPr/>
+        <p:txBody>
+          <a:bodyPr/>
+          <a:lstStyle/>
+          <a:p>
+            <a:r>
+              <a:rPr lang="en-US" dirty="0"/>
+              <a:t>Sampling from </a:t>
+            </a:r>
+            <a:r>
+              <a:rPr lang="en-US" dirty="0" err="1"/>
+              <a:t>OpenWebText</a:t>
+            </a:r>
+            <a:endParaRPr lang="en-DK" dirty="0"/>
+          </a:p>
+        </p:txBody>
+      </p:sp>
+      <p:pic>
+        <p:nvPicPr>
+          <p:cNvPr id="5" name="Picture 4">
+            <a:extLst>
+              <a:ext uri="{FF2B5EF4-FFF2-40B4-BE49-F238E27FC236}">
+                <a16:creationId xmlns:a16="http://schemas.microsoft.com/office/drawing/2014/main" id="{60BD4FF5-2ACA-5E82-63AC-FB5656DE5C52}"/>
+              </a:ext>
+            </a:extLst>
+          </p:cNvPr>
+          <p:cNvPicPr>
+            <a:picLocks noChangeAspect="1"/>
+          </p:cNvPicPr>
+          <p:nvPr/>
+        </p:nvPicPr>
+        <p:blipFill>
+          <a:blip r:embed="rId2"/>
+          <a:stretch>
+            <a:fillRect/>
+          </a:stretch>
+        </p:blipFill>
+        <p:spPr>
+          <a:xfrm>
+            <a:off x="838200" y="1488331"/>
+            <a:ext cx="8555777" cy="4787716"/>
+          </a:xfrm>
+          <a:prstGeom prst="rect">
+            <a:avLst/>
+          </a:prstGeom>
+        </p:spPr>
+      </p:pic>
+    </p:spTree>
+    <p:extLst>
+      <p:ext uri="{BB962C8B-B14F-4D97-AF65-F5344CB8AC3E}">
+        <p14:creationId xmlns:p14="http://schemas.microsoft.com/office/powerpoint/2010/main" val="4115882464"/>
+      </p:ext>
+    </p:extLst>
+  </p:cSld>
+  <p:clrMapOvr>
+    <a:masterClrMapping/>
+  </p:clrMapOvr>
+</p:sld>
+</file>
+
+<file path=ppt/slides/slide8.xml><?xml version="1.0" encoding="utf-8"?>
+<p:sld xmlns:a="http://schemas.openxmlformats.org/drawingml/2006/main" xmlns:r="http://schemas.openxmlformats.org/officeDocument/2006/relationships" xmlns:p="http://schemas.openxmlformats.org/presentationml/2006/main">
+  <p:cSld>
+    <p:spTree>
+      <p:nvGrpSpPr>
+        <p:cNvPr id="1" name=""/>
+        <p:cNvGrpSpPr/>
+        <p:nvPr/>
+      </p:nvGrpSpPr>
+      <p:grpSpPr>
+        <a:xfrm>
+          <a:off x="0" y="0"/>
+          <a:ext cx="0" cy="0"/>
+          <a:chOff x="0" y="0"/>
+          <a:chExt cx="0" cy="0"/>
+        </a:xfrm>
+      </p:grpSpPr>
+      <p:pic>
+        <p:nvPicPr>
+          <p:cNvPr id="5" name="Picture 4">
+            <a:extLst>
+              <a:ext uri="{FF2B5EF4-FFF2-40B4-BE49-F238E27FC236}">
+                <a16:creationId xmlns:a16="http://schemas.microsoft.com/office/drawing/2014/main" id="{6D16E4FB-4C5D-8BF4-77CB-DCB69B5665B1}"/>
+              </a:ext>
+            </a:extLst>
+          </p:cNvPr>
+          <p:cNvPicPr>
+            <a:picLocks noChangeAspect="1"/>
+          </p:cNvPicPr>
+          <p:nvPr/>
+        </p:nvPicPr>
+        <p:blipFill>
+          <a:blip r:embed="rId2"/>
+          <a:stretch>
+            <a:fillRect/>
+          </a:stretch>
+        </p:blipFill>
+        <p:spPr>
+          <a:xfrm>
+            <a:off x="817124" y="686295"/>
+            <a:ext cx="9866651" cy="5485409"/>
+          </a:xfrm>
+          <a:prstGeom prst="rect">
+            <a:avLst/>
+          </a:prstGeom>
+        </p:spPr>
+      </p:pic>
+    </p:spTree>
+    <p:extLst>
+      <p:ext uri="{BB962C8B-B14F-4D97-AF65-F5344CB8AC3E}">
+        <p14:creationId xmlns:p14="http://schemas.microsoft.com/office/powerpoint/2010/main" val="4065009930"/>
+      </p:ext>
+    </p:extLst>
+  </p:cSld>
+  <p:clrMapOvr>
+    <a:masterClrMapping/>
+  </p:clrMapOvr>
+</p:sld>
+</file>
+
+<file path=ppt/slides/slide9.xml><?xml version="1.0" encoding="utf-8"?>
+<p:sld xmlns:a="http://schemas.openxmlformats.org/drawingml/2006/main" xmlns:r="http://schemas.openxmlformats.org/officeDocument/2006/relationships" xmlns:p="http://schemas.openxmlformats.org/presentationml/2006/main">
+  <p:cSld>
+    <p:spTree>
+      <p:nvGrpSpPr>
+        <p:cNvPr id="1" name=""/>
+        <p:cNvGrpSpPr/>
+        <p:nvPr/>
+      </p:nvGrpSpPr>
+      <p:grpSpPr>
+        <a:xfrm>
+          <a:off x="0" y="0"/>
+          <a:ext cx="0" cy="0"/>
+          <a:chOff x="0" y="0"/>
+          <a:chExt cx="0" cy="0"/>
+        </a:xfrm>
+      </p:grpSpPr>
+      <p:sp>
+        <p:nvSpPr>
+          <p:cNvPr id="2" name="Title 1">
+            <a:extLst>
+              <a:ext uri="{FF2B5EF4-FFF2-40B4-BE49-F238E27FC236}">
+                <a16:creationId xmlns:a16="http://schemas.microsoft.com/office/drawing/2014/main" id="{A974D366-0C25-A3FE-A9E0-83524A78B3F5}"/>
+              </a:ext>
+            </a:extLst>
+          </p:cNvPr>
+          <p:cNvSpPr>
+            <a:spLocks noGrp="1"/>
+          </p:cNvSpPr>
+          <p:nvPr>
+            <p:ph type="title"/>
+          </p:nvPr>
+        </p:nvSpPr>
+        <p:spPr/>
+        <p:txBody>
+          <a:bodyPr/>
+          <a:lstStyle/>
+          <a:p>
+            <a:r>
+              <a:rPr lang="en-US" dirty="0"/>
+              <a:t>Sampling from MMLU auxiliary train</a:t>
+            </a:r>
+            <a:endParaRPr lang="en-DK" dirty="0"/>
+          </a:p>
+        </p:txBody>
+      </p:sp>
+      <p:sp>
+        <p:nvSpPr>
+          <p:cNvPr id="5" name="TextBox 4">
+            <a:extLst>
+              <a:ext uri="{FF2B5EF4-FFF2-40B4-BE49-F238E27FC236}">
+                <a16:creationId xmlns:a16="http://schemas.microsoft.com/office/drawing/2014/main" id="{2BEFFA93-070A-05B8-A54F-EA8D32B24FFA}"/>
+              </a:ext>
+            </a:extLst>
+          </p:cNvPr>
+          <p:cNvSpPr txBox="1"/>
+          <p:nvPr/>
+        </p:nvSpPr>
+        <p:spPr>
+          <a:xfrm>
+            <a:off x="838200" y="1906955"/>
+            <a:ext cx="6096000" cy="4247317"/>
+          </a:xfrm>
+          <a:prstGeom prst="rect">
+            <a:avLst/>
+          </a:prstGeom>
+          <a:noFill/>
+        </p:spPr>
+        <p:txBody>
+          <a:bodyPr wrap="square">
+            <a:spAutoFit/>
+          </a:bodyPr>
+          <a:lstStyle/>
+          <a:p>
+            <a:r>
+              <a:rPr lang="en-US" dirty="0"/>
+              <a:t>Math/STEM: </a:t>
+            </a:r>
+            <a:r>
+              <a:rPr lang="en-US" dirty="0">
+                <a:hlinkClick r:id="rId2"/>
+              </a:rPr>
+              <a:t>https://huggingface.co/datasets/open-web-math/open-web-math</a:t>
+            </a:r>
+            <a:r>
+              <a:rPr lang="en-US" dirty="0"/>
+              <a:t> , </a:t>
+            </a:r>
+            <a:r>
+              <a:rPr lang="en-US" dirty="0">
+                <a:hlinkClick r:id="rId3"/>
+              </a:rPr>
+              <a:t>https://huggingface.co/datasets/HuggingFaceTB/finemath</a:t>
+            </a:r>
+            <a:r>
+              <a:rPr lang="en-US" dirty="0"/>
+              <a:t> </a:t>
+            </a:r>
+          </a:p>
+          <a:p>
+            <a:r>
+              <a:rPr lang="en-US" dirty="0"/>
+              <a:t>Legal: </a:t>
+            </a:r>
+            <a:r>
+              <a:rPr lang="en-US" dirty="0">
+                <a:hlinkClick r:id="rId4"/>
+              </a:rPr>
+              <a:t>https://huggingface.co/datasets/pile-of-law/pile-of-law?utm_source=chatgpt.com</a:t>
+            </a:r>
+            <a:r>
+              <a:rPr lang="en-US" dirty="0"/>
+              <a:t> </a:t>
+            </a:r>
+          </a:p>
+          <a:p>
+            <a:r>
+              <a:rPr lang="en-US" dirty="0" err="1"/>
+              <a:t>Litterature</a:t>
+            </a:r>
+            <a:r>
+              <a:rPr lang="en-US" dirty="0"/>
+              <a:t>: </a:t>
+            </a:r>
+            <a:r>
+              <a:rPr lang="en-US" dirty="0">
+                <a:hlinkClick r:id="rId5"/>
+              </a:rPr>
+              <a:t>https://huggingface.co/datasets/ACOSharma/literature/viewer/default/train?row=0</a:t>
+            </a:r>
+            <a:r>
+              <a:rPr lang="en-US" dirty="0"/>
+              <a:t> , </a:t>
+            </a:r>
+            <a:r>
+              <a:rPr lang="en-US" dirty="0">
+                <a:hlinkClick r:id="rId6"/>
+              </a:rPr>
+              <a:t>https://huggingface.co/datasets/TheBritishLibrary/blbooks?utm_source=chatgpt.com</a:t>
+            </a:r>
+            <a:r>
+              <a:rPr lang="en-US" dirty="0"/>
+              <a:t> </a:t>
+            </a:r>
+          </a:p>
+          <a:p>
+            <a:r>
+              <a:rPr lang="en-US" dirty="0"/>
+              <a:t>Medical: </a:t>
+            </a:r>
+            <a:r>
+              <a:rPr lang="en-US" dirty="0">
+                <a:hlinkClick r:id="rId7"/>
+              </a:rPr>
+              <a:t>https://huggingface.co/datasets/armanc/pubmed-rct20k?utm_source=chatgpt.com</a:t>
+            </a:r>
+            <a:r>
+              <a:rPr lang="en-US" dirty="0"/>
+              <a:t> , </a:t>
+            </a:r>
+            <a:r>
+              <a:rPr lang="en-US" dirty="0">
+                <a:hlinkClick r:id="rId8"/>
+              </a:rPr>
+              <a:t>https://huggingface.co/datasets/MedRAG/pubmed?utm_source=chatgpt.com</a:t>
+            </a:r>
+            <a:r>
+              <a:rPr lang="en-US" dirty="0"/>
+              <a:t> </a:t>
+            </a:r>
+          </a:p>
+          <a:p>
+            <a:endParaRPr lang="en-DK" dirty="0"/>
+          </a:p>
+        </p:txBody>
+      </p:sp>
+    </p:spTree>
+    <p:extLst>
+      <p:ext uri="{BB962C8B-B14F-4D97-AF65-F5344CB8AC3E}">
+        <p14:creationId xmlns:p14="http://schemas.microsoft.com/office/powerpoint/2010/main" val="408518595"/>
       </p:ext>
     </p:extLst>
   </p:cSld>

</xml_diff>